<commit_message>
Keep mixed-filler evidence inside its measured boundary
Record the cache-first mixed-filler diagnostic as reproducible evidence and embed a generated backup slide while preserving the quick-run claim boundary. The slide derives every displayed metric from a compact source summary and fail-closes on claim flags, THP backing, work identity, and binary provenance.

Constraint: The N=8 source artifact is a dirty-tree diagnostic and cannot support an equivalence or production performance claim.

Rejected: Present the near-zero mixed-versus-legacy estimate as parity | no preregistered equivalence margin exists.

Confidence: high

Scope-risk: narrow

Directive: Keep B13 diagnostic until a clean committed larger campaign replaces it.

Tested: Four Python unit tests; deterministic SVG/PNG/PPTX regeneration; manifest hashes; PPTX ZIP integrity; CJK scan; git diff check.

Not-tested: Microsoft PowerPoint application round-trip.
</commit_message>
<xml_diff>
--- a/docs/UniAlloc-Qualifier-Core-Deck.pptx
+++ b/docs/UniAlloc-Qualifier-Core-Deck.pptx
@@ -1,52 +1,53 @@
 
 <file path=ppt/presentation.xml><?xml version="1.0" encoding="utf-8"?>
-<p:presentation xmlns:p="http://schemas.openxmlformats.org/presentationml/2006/main">
+<p:presentation xmlns:a="http://schemas.openxmlformats.org/drawingml/2006/main" xmlns:p="http://schemas.openxmlformats.org/presentationml/2006/main" xmlns:r="http://schemas.openxmlformats.org/officeDocument/2006/relationships">
   <p:sldMasterIdLst>
-    <p:sldMasterId xmlns:r="http://schemas.openxmlformats.org/officeDocument/2006/relationships" id="2147483648" r:id="Rfeb7e46cf7ae481d"/>
+    <p:sldMasterId id="2147483648" r:id="Rfeb7e46cf7ae481d"/>
   </p:sldMasterIdLst>
   <p:notesMasterIdLst>
-    <p:notesMasterId xmlns:r="http://schemas.openxmlformats.org/officeDocument/2006/relationships" r:id="R096148ea23d34451"/>
+    <p:notesMasterId r:id="R096148ea23d34451"/>
   </p:notesMasterIdLst>
   <p:sldIdLst>
-    <p:sldId xmlns:r="http://schemas.openxmlformats.org/officeDocument/2006/relationships" id="256" r:id="R63c196c3bca74251"/>
-    <p:sldId xmlns:r="http://schemas.openxmlformats.org/officeDocument/2006/relationships" id="257" r:id="Rcd63a9d0b2904d91"/>
-    <p:sldId xmlns:r="http://schemas.openxmlformats.org/officeDocument/2006/relationships" id="258" r:id="R2e3668cad2ec42dd"/>
-    <p:sldId xmlns:r="http://schemas.openxmlformats.org/officeDocument/2006/relationships" id="259" r:id="R829632f077de4b5a"/>
-    <p:sldId xmlns:r="http://schemas.openxmlformats.org/officeDocument/2006/relationships" id="260" r:id="R2038f12ab8bf4699"/>
-    <p:sldId xmlns:r="http://schemas.openxmlformats.org/officeDocument/2006/relationships" id="261" r:id="R43cd6afaa2224493"/>
-    <p:sldId xmlns:r="http://schemas.openxmlformats.org/officeDocument/2006/relationships" id="262" r:id="Rc190971dacdd4792"/>
-    <p:sldId xmlns:r="http://schemas.openxmlformats.org/officeDocument/2006/relationships" id="263" r:id="R585a53b8740e4eb0"/>
-    <p:sldId xmlns:r="http://schemas.openxmlformats.org/officeDocument/2006/relationships" id="264" r:id="R16e36625c5ba4da4"/>
-    <p:sldId xmlns:r="http://schemas.openxmlformats.org/officeDocument/2006/relationships" id="265" r:id="Rbca4546809ad478c"/>
-    <p:sldId xmlns:r="http://schemas.openxmlformats.org/officeDocument/2006/relationships" id="266" r:id="R4ee0e0f3580648b2"/>
-    <p:sldId xmlns:r="http://schemas.openxmlformats.org/officeDocument/2006/relationships" id="267" r:id="Rdca38b6b2eb44ee0"/>
-    <p:sldId xmlns:r="http://schemas.openxmlformats.org/officeDocument/2006/relationships" id="268" r:id="Rd9b86b031e8e4c64"/>
-    <p:sldId xmlns:r="http://schemas.openxmlformats.org/officeDocument/2006/relationships" id="269" r:id="Re566fc5824e94385"/>
-    <p:sldId xmlns:r="http://schemas.openxmlformats.org/officeDocument/2006/relationships" id="270" r:id="R8bc858a0423f4e37"/>
-    <p:sldId xmlns:r="http://schemas.openxmlformats.org/officeDocument/2006/relationships" id="271" r:id="Re5258a5e150f44d5"/>
-    <p:sldId xmlns:r="http://schemas.openxmlformats.org/officeDocument/2006/relationships" id="272" r:id="R5ba148865ef145ab"/>
-    <p:sldId xmlns:r="http://schemas.openxmlformats.org/officeDocument/2006/relationships" id="273" r:id="Rd1c42f6e0d494f03"/>
-    <p:sldId xmlns:r="http://schemas.openxmlformats.org/officeDocument/2006/relationships" id="274" r:id="Rc49f8f47dd984497"/>
-    <p:sldId xmlns:r="http://schemas.openxmlformats.org/officeDocument/2006/relationships" id="275" r:id="R045a93e68c964035"/>
-    <p:sldId xmlns:r="http://schemas.openxmlformats.org/officeDocument/2006/relationships" id="276" r:id="R4224af46de5b41ee"/>
-    <p:sldId xmlns:r="http://schemas.openxmlformats.org/officeDocument/2006/relationships" id="277" r:id="R1a28070ae0814b6d"/>
-    <p:sldId xmlns:r="http://schemas.openxmlformats.org/officeDocument/2006/relationships" id="278" r:id="R41339f6decc74beb"/>
-    <p:sldId xmlns:r="http://schemas.openxmlformats.org/officeDocument/2006/relationships" id="279" r:id="R1246ff7312a7454d"/>
-    <p:sldId xmlns:r="http://schemas.openxmlformats.org/officeDocument/2006/relationships" id="280" r:id="Rbf669c292ece49d0"/>
-    <p:sldId xmlns:r="http://schemas.openxmlformats.org/officeDocument/2006/relationships" id="281" r:id="R870798f383844fd4"/>
-    <p:sldId xmlns:r="http://schemas.openxmlformats.org/officeDocument/2006/relationships" id="282" r:id="Reb5696d6811a41a6"/>
-    <p:sldId xmlns:r="http://schemas.openxmlformats.org/officeDocument/2006/relationships" id="283" r:id="R8ec0e12b580049fc"/>
-    <p:sldId xmlns:r="http://schemas.openxmlformats.org/officeDocument/2006/relationships" id="284" r:id="Rc20cdb1d59774f37"/>
-    <p:sldId xmlns:r="http://schemas.openxmlformats.org/officeDocument/2006/relationships" id="285" r:id="R75491b77a75545ce"/>
-    <p:sldId xmlns:r="http://schemas.openxmlformats.org/officeDocument/2006/relationships" id="286" r:id="R474f781b0f624162"/>
+    <p:sldId id="256" r:id="R63c196c3bca74251"/>
+    <p:sldId id="257" r:id="Rcd63a9d0b2904d91"/>
+    <p:sldId id="258" r:id="R2e3668cad2ec42dd"/>
+    <p:sldId id="259" r:id="R829632f077de4b5a"/>
+    <p:sldId id="260" r:id="R2038f12ab8bf4699"/>
+    <p:sldId id="261" r:id="R43cd6afaa2224493"/>
+    <p:sldId id="262" r:id="Rc190971dacdd4792"/>
+    <p:sldId id="263" r:id="R585a53b8740e4eb0"/>
+    <p:sldId id="264" r:id="R16e36625c5ba4da4"/>
+    <p:sldId id="265" r:id="Rbca4546809ad478c"/>
+    <p:sldId id="266" r:id="R4ee0e0f3580648b2"/>
+    <p:sldId id="267" r:id="Rdca38b6b2eb44ee0"/>
+    <p:sldId id="268" r:id="Rd9b86b031e8e4c64"/>
+    <p:sldId id="269" r:id="Re566fc5824e94385"/>
+    <p:sldId id="270" r:id="R8bc858a0423f4e37"/>
+    <p:sldId id="271" r:id="Re5258a5e150f44d5"/>
+    <p:sldId id="272" r:id="R5ba148865ef145ab"/>
+    <p:sldId id="273" r:id="Rd1c42f6e0d494f03"/>
+    <p:sldId id="274" r:id="Rc49f8f47dd984497"/>
+    <p:sldId id="275" r:id="R045a93e68c964035"/>
+    <p:sldId id="276" r:id="R4224af46de5b41ee"/>
+    <p:sldId id="277" r:id="R1a28070ae0814b6d"/>
+    <p:sldId id="278" r:id="R41339f6decc74beb"/>
+    <p:sldId id="279" r:id="R1246ff7312a7454d"/>
+    <p:sldId id="280" r:id="Rbf669c292ece49d0"/>
+    <p:sldId id="281" r:id="R870798f383844fd4"/>
+    <p:sldId id="282" r:id="Reb5696d6811a41a6"/>
+    <p:sldId id="283" r:id="R8ec0e12b580049fc"/>
+    <p:sldId id="284" r:id="Rc20cdb1d59774f37"/>
+    <p:sldId id="285" r:id="R75491b77a75545ce"/>
+    <p:sldId id="286" r:id="R474f781b0f624162"/>
+    <p:sldId id="287" r:id="RlifetimeFastpathB13"/>
   </p:sldIdLst>
   <p:sldSz cx="12192000" cy="6858000"/>
   <p:notesSz cx="6858000" cy="9144000"/>
   <p:defaultTextStyle>
-    <a:defPPr xmlns:a="http://schemas.openxmlformats.org/drawingml/2006/main">
+    <a:defPPr>
       <a:defRPr lang="en-US"/>
     </a:defPPr>
-    <a:lvl1pPr xmlns:a="http://schemas.openxmlformats.org/drawingml/2006/main" marL="0" indent="0" algn="l" defTabSz="914400">
+    <a:lvl1pPr marL="0" indent="0" algn="l" defTabSz="914400">
       <a:defRPr sz="1800" kern="1200">
         <a:solidFill>
           <a:schemeClr val="tx1"/>
@@ -56,7 +57,7 @@
         <a:cs typeface="+mn-cs"/>
       </a:defRPr>
     </a:lvl1pPr>
-    <a:lvl2pPr xmlns:a="http://schemas.openxmlformats.org/drawingml/2006/main" marL="457200" indent="0" algn="l" defTabSz="914400">
+    <a:lvl2pPr marL="457200" indent="0" algn="l" defTabSz="914400">
       <a:defRPr sz="1800" kern="1200">
         <a:solidFill>
           <a:schemeClr val="tx1"/>
@@ -66,7 +67,7 @@
         <a:cs typeface="+mn-cs"/>
       </a:defRPr>
     </a:lvl2pPr>
-    <a:lvl3pPr xmlns:a="http://schemas.openxmlformats.org/drawingml/2006/main" marL="914400" indent="0" algn="l" defTabSz="914400">
+    <a:lvl3pPr marL="914400" indent="0" algn="l" defTabSz="914400">
       <a:defRPr sz="1800" kern="1200">
         <a:solidFill>
           <a:schemeClr val="tx1"/>
@@ -76,7 +77,7 @@
         <a:cs typeface="+mn-cs"/>
       </a:defRPr>
     </a:lvl3pPr>
-    <a:lvl4pPr xmlns:a="http://schemas.openxmlformats.org/drawingml/2006/main" marL="1371600" indent="0" algn="l" defTabSz="914400">
+    <a:lvl4pPr marL="1371600" indent="0" algn="l" defTabSz="914400">
       <a:defRPr sz="1800" kern="1200">
         <a:solidFill>
           <a:schemeClr val="tx1"/>
@@ -86,7 +87,7 @@
         <a:cs typeface="+mn-cs"/>
       </a:defRPr>
     </a:lvl4pPr>
-    <a:lvl5pPr xmlns:a="http://schemas.openxmlformats.org/drawingml/2006/main" marL="1828800" indent="0" algn="l" defTabSz="914400">
+    <a:lvl5pPr marL="1828800" indent="0" algn="l" defTabSz="914400">
       <a:defRPr sz="1800" kern="1200">
         <a:solidFill>
           <a:schemeClr val="tx1"/>
@@ -96,7 +97,7 @@
         <a:cs typeface="+mn-cs"/>
       </a:defRPr>
     </a:lvl5pPr>
-    <a:lvl6pPr xmlns:a="http://schemas.openxmlformats.org/drawingml/2006/main" marL="2286000" indent="0" algn="l" defTabSz="914400">
+    <a:lvl6pPr marL="2286000" indent="0" algn="l" defTabSz="914400">
       <a:defRPr sz="1800" kern="1200">
         <a:solidFill>
           <a:schemeClr val="tx1"/>
@@ -106,7 +107,7 @@
         <a:cs typeface="+mn-cs"/>
       </a:defRPr>
     </a:lvl6pPr>
-    <a:lvl7pPr xmlns:a="http://schemas.openxmlformats.org/drawingml/2006/main" marL="2743200" indent="0" algn="l" defTabSz="914400">
+    <a:lvl7pPr marL="2743200" indent="0" algn="l" defTabSz="914400">
       <a:defRPr sz="1800" kern="1200">
         <a:solidFill>
           <a:schemeClr val="tx1"/>
@@ -116,7 +117,7 @@
         <a:cs typeface="+mn-cs"/>
       </a:defRPr>
     </a:lvl7pPr>
-    <a:lvl8pPr xmlns:a="http://schemas.openxmlformats.org/drawingml/2006/main" marL="3200400" indent="0" algn="l" defTabSz="914400">
+    <a:lvl8pPr marL="3200400" indent="0" algn="l" defTabSz="914400">
       <a:defRPr sz="1800" kern="1200">
         <a:solidFill>
           <a:schemeClr val="tx1"/>
@@ -126,7 +127,7 @@
         <a:cs typeface="+mn-cs"/>
       </a:defRPr>
     </a:lvl8pPr>
-    <a:lvl9pPr xmlns:a="http://schemas.openxmlformats.org/drawingml/2006/main" marL="3657600" indent="0" algn="l" defTabSz="914400">
+    <a:lvl9pPr marL="3657600" indent="0" algn="l" defTabSz="914400">
       <a:defRPr sz="1800" kern="1200">
         <a:solidFill>
           <a:schemeClr val="tx1"/>
@@ -1388,7 +1389,7 @@
 </file>
 
 <file path=ppt/notesSlides/notesSlide20.xml><?xml version="1.0" encoding="utf-8"?>
-<p:notes xmlns:p="http://schemas.openxmlformats.org/presentationml/2006/main">
+<p:notes xmlns:a="http://schemas.openxmlformats.org/drawingml/2006/main" xmlns:p="http://schemas.openxmlformats.org/presentationml/2006/main">
   <p:cSld>
     <p:spTree>
       <p:nvGrpSpPr>
@@ -1397,13 +1398,13 @@
         <p:nvPr/>
       </p:nvGrpSpPr>
       <p:grpSpPr>
-        <a:xfrm xmlns:a="http://schemas.openxmlformats.org/drawingml/2006/main"/>
+        <a:xfrm/>
       </p:grpSpPr>
       <p:sp>
         <p:nvSpPr>
           <p:cNvPr id="2" name="Slide Image Placeholder 1"/>
           <p:cNvSpPr>
-            <a:spLocks xmlns:a="http://schemas.openxmlformats.org/drawingml/2006/main" noGrp="1"/>
+            <a:spLocks noGrp="1"/>
           </p:cNvSpPr>
           <p:nvPr>
             <p:ph type="sldImg" idx="0"/>
@@ -1415,7 +1416,7 @@
         <p:nvSpPr>
           <p:cNvPr id="3" name="Notes Placeholder 2"/>
           <p:cNvSpPr>
-            <a:spLocks xmlns:a="http://schemas.openxmlformats.org/drawingml/2006/main" noGrp="1"/>
+            <a:spLocks noGrp="1"/>
           </p:cNvSpPr>
           <p:nvPr>
             <p:ph type="body" idx="1"/>
@@ -1423,25 +1424,30 @@
         </p:nvSpPr>
         <p:spPr/>
         <p:txBody>
-          <a:bodyPr xmlns:a="http://schemas.openxmlformats.org/drawingml/2006/main"/>
-          <a:lstStyle xmlns:a="http://schemas.openxmlformats.org/drawingml/2006/main"/>
-          <a:p xmlns:a="http://schemas.openxmlformats.org/drawingml/2006/main">
+          <a:bodyPr/>
+          <a:lstStyle/>
+          <a:p>
             <a:r>
               <a:t>Accounting repair 1228f71: one single-thread micro diagnostic, 24 identities, 2.4M typed operations, 72.338 -&gt; 54.808 ns/op.</a:t>
             </a:r>
           </a:p>
-          <a:p xmlns:a="http://schemas.openxmlformats.org/drawingml/2006/main">
+          <a:p>
             <a:r>
               <a:t>No median/range; do not report a stable percentage or paper-level claim.</a:t>
             </a:r>
           </a:p>
+          <a:p>
+            <a:r>
+              <a:t>Backup jump: B13 - cache-first mixed filling, physical-backing gates, and peak RSS. Current diagnostic; keep the claim-grade boundary visible.</a:t>
+            </a:r>
+          </a:p>
         </p:txBody>
       </p:sp>
       <p:sp>
         <p:nvSpPr>
           <p:cNvPr id="4" name="Slide Number Placeholder 3"/>
           <p:cNvSpPr>
-            <a:spLocks xmlns:a="http://schemas.openxmlformats.org/drawingml/2006/main" noGrp="1"/>
+            <a:spLocks noGrp="1"/>
           </p:cNvSpPr>
           <p:nvPr>
             <p:ph type="sldNum" idx="5"/>
@@ -1449,15 +1455,15 @@
         </p:nvSpPr>
         <p:spPr/>
         <p:txBody>
-          <a:bodyPr xmlns:a="http://schemas.openxmlformats.org/drawingml/2006/main"/>
-          <a:lstStyle xmlns:a="http://schemas.openxmlformats.org/drawingml/2006/main"/>
-          <a:p xmlns:a="http://schemas.openxmlformats.org/drawingml/2006/main"/>
+          <a:bodyPr/>
+          <a:lstStyle/>
+          <a:p/>
         </p:txBody>
       </p:sp>
     </p:spTree>
   </p:cSld>
   <p:clrMapOvr>
-    <a:masterClrMapping xmlns:a="http://schemas.openxmlformats.org/drawingml/2006/main"/>
+    <a:masterClrMapping/>
   </p:clrMapOvr>
 </p:notes>
 </file>
@@ -1741,7 +1747,7 @@
 </file>
 
 <file path=ppt/notesSlides/notesSlide25.xml><?xml version="1.0" encoding="utf-8"?>
-<p:notes xmlns:p="http://schemas.openxmlformats.org/presentationml/2006/main">
+<p:notes xmlns:a="http://schemas.openxmlformats.org/drawingml/2006/main" xmlns:p="http://schemas.openxmlformats.org/presentationml/2006/main">
   <p:cSld>
     <p:spTree>
       <p:nvGrpSpPr>
@@ -1750,13 +1756,13 @@
         <p:nvPr/>
       </p:nvGrpSpPr>
       <p:grpSpPr>
-        <a:xfrm xmlns:a="http://schemas.openxmlformats.org/drawingml/2006/main"/>
+        <a:xfrm/>
       </p:grpSpPr>
       <p:sp>
         <p:nvSpPr>
           <p:cNvPr id="2" name="Slide Image Placeholder 1"/>
           <p:cNvSpPr>
-            <a:spLocks xmlns:a="http://schemas.openxmlformats.org/drawingml/2006/main" noGrp="1"/>
+            <a:spLocks noGrp="1"/>
           </p:cNvSpPr>
           <p:nvPr>
             <p:ph type="sldImg" idx="0"/>
@@ -1768,7 +1774,7 @@
         <p:nvSpPr>
           <p:cNvPr id="3" name="Notes Placeholder 2"/>
           <p:cNvSpPr>
-            <a:spLocks xmlns:a="http://schemas.openxmlformats.org/drawingml/2006/main" noGrp="1"/>
+            <a:spLocks noGrp="1"/>
           </p:cNvSpPr>
           <p:nvPr>
             <p:ph type="body" idx="1"/>
@@ -1776,16 +1782,21 @@
         </p:nvSpPr>
         <p:spPr/>
         <p:txBody>
-          <a:bodyPr xmlns:a="http://schemas.openxmlformats.org/drawingml/2006/main"/>
-          <a:lstStyle xmlns:a="http://schemas.openxmlformats.org/drawingml/2006/main"/>
-          <a:p xmlns:a="http://schemas.openxmlformats.org/drawingml/2006/main"/>
+          <a:bodyPr/>
+          <a:lstStyle/>
+          <a:p/>
+          <a:p>
+            <a:r>
+              <a:t>Backup jump: B13 - SWC N=8 packing, fastpath, time, RSS, and per-sample backing gates. No default or Google TCMalloc comparison.</a:t>
+            </a:r>
+          </a:p>
         </p:txBody>
       </p:sp>
       <p:sp>
         <p:nvSpPr>
           <p:cNvPr id="4" name="Slide Number Placeholder 3"/>
           <p:cNvSpPr>
-            <a:spLocks xmlns:a="http://schemas.openxmlformats.org/drawingml/2006/main" noGrp="1"/>
+            <a:spLocks noGrp="1"/>
           </p:cNvSpPr>
           <p:nvPr>
             <p:ph type="sldNum" idx="5"/>
@@ -1793,15 +1804,15 @@
         </p:nvSpPr>
         <p:spPr/>
         <p:txBody>
-          <a:bodyPr xmlns:a="http://schemas.openxmlformats.org/drawingml/2006/main"/>
-          <a:lstStyle xmlns:a="http://schemas.openxmlformats.org/drawingml/2006/main"/>
-          <a:p xmlns:a="http://schemas.openxmlformats.org/drawingml/2006/main"/>
+          <a:bodyPr/>
+          <a:lstStyle/>
+          <a:p/>
         </p:txBody>
       </p:sp>
     </p:spTree>
   </p:cSld>
   <p:clrMapOvr>
-    <a:masterClrMapping xmlns:a="http://schemas.openxmlformats.org/drawingml/2006/main"/>
+    <a:masterClrMapping/>
   </p:clrMapOvr>
 </p:notes>
 </file>
@@ -26091,6 +26102,55 @@
 </p:sld>
 </file>
 
+<file path=ppt/slides/slide32.xml><?xml version="1.0" encoding="utf-8"?>
+<p:sld xmlns:a="http://schemas.openxmlformats.org/drawingml/2006/main" xmlns:r="http://schemas.openxmlformats.org/officeDocument/2006/relationships" xmlns:p="http://schemas.openxmlformats.org/presentationml/2006/main" showMasterSp="0">
+  <p:cSld name="B13 Lifetime Mixed Fastpath Evidence">
+    <p:spTree>
+      <p:nvGrpSpPr>
+        <p:cNvPr id="1" name=""/>
+        <p:cNvGrpSpPr/>
+        <p:nvPr/>
+      </p:nvGrpSpPr>
+      <p:grpSpPr>
+        <a:xfrm>
+          <a:off x="0" y="0"/>
+          <a:ext cx="0" cy="0"/>
+          <a:chOff x="0" y="0"/>
+          <a:chExt cx="0" cy="0"/>
+        </a:xfrm>
+      </p:grpSpPr>
+      <p:pic>
+        <p:nvPicPr>
+          <p:cNvPr id="2" name="B13 Lifetime Mixed Fastpath Evidence" descr="Source-bound SWC mixed-filler diagnostic; claim eligibility false"/>
+          <p:cNvPicPr>
+            <a:picLocks noChangeAspect="1"/>
+          </p:cNvPicPr>
+          <p:nvPr/>
+        </p:nvPicPr>
+        <p:blipFill>
+          <a:blip r:embed="RlifetimeFastpathImage"/>
+          <a:stretch>
+            <a:fillRect/>
+          </a:stretch>
+        </p:blipFill>
+        <p:spPr>
+          <a:xfrm>
+            <a:off x="0" y="0"/>
+            <a:ext cx="12192000" cy="6858000"/>
+          </a:xfrm>
+          <a:prstGeom prst="rect">
+            <a:avLst/>
+          </a:prstGeom>
+        </p:spPr>
+      </p:pic>
+    </p:spTree>
+  </p:cSld>
+  <p:clrMapOvr>
+    <a:masterClrMapping/>
+  </p:clrMapOvr>
+</p:sld>
+</file>
+
 <file path=ppt/slides/slide4.xml><?xml version="1.0" encoding="utf-8"?>
 <p:sld xmlns:p="http://schemas.openxmlformats.org/presentationml/2006/main">
   <p:cSld>

</xml_diff>